<commit_message>
Fix slides 8, 11, 13 to match the book and current demo
- Slide 8: resampling example belongs to data structure space (Fig. 11.6)
- Slide 11: blender = handling space touched by more than one interaction
- Slide 13: table updated for automatic Grand Tour, fisheye, replace/add selection, unlink views
- Ignore PowerPoint lock files
</commit_message>
<xml_diff>
--- a/Slide_nhom18_GK_moi.pptx
+++ b/Slide_nhom18_GK_moi.pptx
@@ -1426,7 +1426,7 @@
           <a:p>
             <a:fld id="{5BCAD085-E8A6-8845-BD4E-CB4CCA059FC4}" type="datetimeFigureOut">
               <a:rPr lang="en-US" smtClean="0"/>
-              <a:t>07/10/2026</a:t>
+              <a:t>08/10/2026</a:t>
             </a:fld>
             <a:endParaRPr lang="en-US"/>
           </a:p>
@@ -1596,7 +1596,7 @@
           <a:p>
             <a:fld id="{5BCAD085-E8A6-8845-BD4E-CB4CCA059FC4}" type="datetimeFigureOut">
               <a:rPr lang="en-US" smtClean="0"/>
-              <a:t>07/10/2026</a:t>
+              <a:t>08/10/2026</a:t>
             </a:fld>
             <a:endParaRPr lang="en-US"/>
           </a:p>
@@ -1776,7 +1776,7 @@
           <a:p>
             <a:fld id="{5BCAD085-E8A6-8845-BD4E-CB4CCA059FC4}" type="datetimeFigureOut">
               <a:rPr lang="en-US" smtClean="0"/>
-              <a:t>07/10/2026</a:t>
+              <a:t>08/10/2026</a:t>
             </a:fld>
             <a:endParaRPr lang="en-US"/>
           </a:p>
@@ -1946,7 +1946,7 @@
           <a:p>
             <a:fld id="{5BCAD085-E8A6-8845-BD4E-CB4CCA059FC4}" type="datetimeFigureOut">
               <a:rPr lang="en-US" smtClean="0"/>
-              <a:t>07/10/2026</a:t>
+              <a:t>08/10/2026</a:t>
             </a:fld>
             <a:endParaRPr lang="en-US"/>
           </a:p>
@@ -2192,7 +2192,7 @@
           <a:p>
             <a:fld id="{5BCAD085-E8A6-8845-BD4E-CB4CCA059FC4}" type="datetimeFigureOut">
               <a:rPr lang="en-US" smtClean="0"/>
-              <a:t>07/10/2026</a:t>
+              <a:t>08/10/2026</a:t>
             </a:fld>
             <a:endParaRPr lang="en-US"/>
           </a:p>
@@ -2480,7 +2480,7 @@
           <a:p>
             <a:fld id="{5BCAD085-E8A6-8845-BD4E-CB4CCA059FC4}" type="datetimeFigureOut">
               <a:rPr lang="en-US" smtClean="0"/>
-              <a:t>07/10/2026</a:t>
+              <a:t>08/10/2026</a:t>
             </a:fld>
             <a:endParaRPr lang="en-US"/>
           </a:p>
@@ -2902,7 +2902,7 @@
           <a:p>
             <a:fld id="{5BCAD085-E8A6-8845-BD4E-CB4CCA059FC4}" type="datetimeFigureOut">
               <a:rPr lang="en-US" smtClean="0"/>
-              <a:t>07/10/2026</a:t>
+              <a:t>08/10/2026</a:t>
             </a:fld>
             <a:endParaRPr lang="en-US"/>
           </a:p>
@@ -3020,7 +3020,7 @@
           <a:p>
             <a:fld id="{5BCAD085-E8A6-8845-BD4E-CB4CCA059FC4}" type="datetimeFigureOut">
               <a:rPr lang="en-US" smtClean="0"/>
-              <a:t>07/10/2026</a:t>
+              <a:t>08/10/2026</a:t>
             </a:fld>
             <a:endParaRPr lang="en-US"/>
           </a:p>
@@ -3115,7 +3115,7 @@
           <a:p>
             <a:fld id="{5BCAD085-E8A6-8845-BD4E-CB4CCA059FC4}" type="datetimeFigureOut">
               <a:rPr lang="en-US" smtClean="0"/>
-              <a:t>07/10/2026</a:t>
+              <a:t>08/10/2026</a:t>
             </a:fld>
             <a:endParaRPr lang="en-US"/>
           </a:p>
@@ -3392,7 +3392,7 @@
           <a:p>
             <a:fld id="{5BCAD085-E8A6-8845-BD4E-CB4CCA059FC4}" type="datetimeFigureOut">
               <a:rPr lang="en-US" smtClean="0"/>
-              <a:t>07/10/2026</a:t>
+              <a:t>08/10/2026</a:t>
             </a:fld>
             <a:endParaRPr lang="en-US"/>
           </a:p>
@@ -3645,7 +3645,7 @@
           <a:p>
             <a:fld id="{5BCAD085-E8A6-8845-BD4E-CB4CCA059FC4}" type="datetimeFigureOut">
               <a:rPr lang="en-US" smtClean="0"/>
-              <a:t>07/10/2026</a:t>
+              <a:t>08/10/2026</a:t>
             </a:fld>
             <a:endParaRPr lang="en-US"/>
           </a:p>
@@ -3858,7 +3858,7 @@
           <a:p>
             <a:fld id="{5BCAD085-E8A6-8845-BD4E-CB4CCA059FC4}" type="datetimeFigureOut">
               <a:rPr lang="en-US" smtClean="0"/>
-              <a:t>07/10/2026</a:t>
+              <a:t>08/10/2026</a:t>
             </a:fld>
             <a:endParaRPr lang="en-US"/>
           </a:p>
@@ -4506,8 +4506,8 @@
         </p:nvSpPr>
         <p:spPr>
           <a:xfrm>
-            <a:off x="548640" y="347472"/>
-            <a:ext cx="11064240" cy="685800"/>
+            <a:off x="548640" y="417989"/>
+            <a:ext cx="11064240" cy="544765"/>
           </a:xfrm>
           <a:prstGeom prst="rect">
             <a:avLst/>
@@ -4532,7 +4532,43 @@
                 </a:solidFill>
                 <a:latin typeface="Segoe UI"/>
               </a:rPr>
-              <a:t>Không gian Đối tượng vs. Cấu trúc Trực quan</a:t>
+              <a:t>Không gian Đối tượng </a:t>
+            </a:r>
+            <a:r>
+              <a:rPr sz="3000" b="1" i="0" smtClean="0">
+                <a:solidFill>
+                  <a:srgbClr val="404040"/>
+                </a:solidFill>
+                <a:latin typeface="Segoe UI"/>
+              </a:rPr>
+              <a:t>vs</a:t>
+            </a:r>
+            <a:r>
+              <a:rPr lang="vi-VN" sz="3000" b="1" i="0" smtClean="0">
+                <a:solidFill>
+                  <a:srgbClr val="404040"/>
+                </a:solidFill>
+                <a:latin typeface="Segoe UI"/>
+              </a:rPr>
+              <a:t> </a:t>
+            </a:r>
+            <a:r>
+              <a:rPr sz="3000" b="1" i="0" smtClean="0">
+                <a:solidFill>
+                  <a:srgbClr val="404040"/>
+                </a:solidFill>
+                <a:latin typeface="Segoe UI"/>
+              </a:rPr>
+              <a:t>Cấu </a:t>
+            </a:r>
+            <a:r>
+              <a:rPr sz="3000" b="1" i="0">
+                <a:solidFill>
+                  <a:srgbClr val="404040"/>
+                </a:solidFill>
+                <a:latin typeface="Segoe UI"/>
+              </a:rPr>
+              <a:t>trúc Trực quan</a:t>
             </a:r>
           </a:p>
         </p:txBody>
@@ -5876,7 +5912,7 @@
                 </a:solidFill>
                 <a:latin typeface="Segoe UI"/>
               </a:rPr>
-              <a:t>Cách xử lý vùng giao giữa phần bị biến đổi và phần giữ nguyên.</a:t>
+              <a:t>Cách xử lý phần không gian bị nhiều hơn một tương tác chồng lên nhau.</a:t>
             </a:r>
           </a:p>
         </p:txBody>
@@ -5915,7 +5951,7 @@
                 </a:solidFill>
                 <a:latin typeface="Segoe UI"/>
               </a:rPr>
-              <a:t>Ví dụ kính lúp (fisheye): Phạm vi = vùng kính; Tiêu điểm = tâm kính; Biến đổi = hàm phóng đại; Bộ hòa trộn = làm mượt viền kính.</a:t>
+              <a:t>Ví dụ kính lúp (fisheye): Phạm vi = vùng kính; Tiêu điểm = tâm kính; Biến đổi = hàm phóng đại; Bộ hòa trộn = cách xử lý chỗ hai kính chồng nhau.</a:t>
             </a:r>
           </a:p>
         </p:txBody>
@@ -8176,7 +8212,7 @@
                           </a:solidFill>
                           <a:latin typeface="Segoe UI"/>
                         </a:rPr>
-                        <a:t>Scatter 2D Tuổi – Thu nhập; Scatter 3D</a:t>
+                        <a:t>Grand Tour (chiếu 2D tự động); Scatter 2D Tuổi – Thu nhập</a:t>
                       </a:r>
                     </a:p>
                   </a:txBody>
@@ -8198,7 +8234,7 @@
                           </a:solidFill>
                           <a:latin typeface="Segoe UI"/>
                         </a:rPr>
-                        <a:t>Pan, Zoom; xoay 3D (Grand Tour)</a:t>
+                        <a:t>Grand Tour tự động, chỉnh kích thước bước; Pan, Zoom</a:t>
                       </a:r>
                     </a:p>
                   </a:txBody>
@@ -8271,7 +8307,7 @@
                           </a:solidFill>
                           <a:latin typeface="Segoe UI"/>
                         </a:rPr>
-                        <a:t>Box/Lasso Select: điểm chọn nổi bật, thống kê tự cập nhật</a:t>
+                        <a:t>Box/Lasso Select, chọn thay thế hoặc cộng thêm; thống kê tự cập nhật</a:t>
                       </a:r>
                     </a:p>
                   </a:txBody>
@@ -8563,7 +8599,7 @@
                           </a:solidFill>
                           <a:latin typeface="Segoe UI"/>
                         </a:rPr>
-                        <a:t>Chọn nhóm: cả 3 biểu đồ cùng highlight</a:t>
+                        <a:t>Chọn nhóm: cả 3 biểu đồ cùng highlight; tách liên kết từng khung</a:t>
                       </a:r>
                     </a:p>
                   </a:txBody>
@@ -8614,7 +8650,7 @@
                           </a:solidFill>
                           <a:latin typeface="Segoe UI"/>
                         </a:rPr>
-                        <a:t>Overview + Detail</a:t>
+                        <a:t>Biến dạng Fisheye</a:t>
                       </a:r>
                     </a:p>
                   </a:txBody>
@@ -8636,7 +8672,7 @@
                           </a:solidFill>
                           <a:latin typeface="Segoe UI"/>
                         </a:rPr>
-                        <a:t>Toàn cảnh 1.470 nhân viên, phóng chi tiết vùng chọn</a:t>
+                        <a:t>Phóng to tiêu điểm, nén phần còn lại; chỉnh tiêu điểm, phạm vi, mức phóng đại</a:t>
                       </a:r>
                     </a:p>
                   </a:txBody>
@@ -14127,8 +14163,8 @@
         </p:nvSpPr>
         <p:spPr>
           <a:xfrm>
-            <a:off x="548640" y="347472"/>
-            <a:ext cx="11064240" cy="685800"/>
+            <a:off x="548640" y="417989"/>
+            <a:ext cx="11064240" cy="544765"/>
           </a:xfrm>
           <a:prstGeom prst="rect">
             <a:avLst/>
@@ -14153,7 +14189,25 @@
                 </a:solidFill>
                 <a:latin typeface="Segoe UI"/>
               </a:rPr>
-              <a:t>Không gian Màn hình vs. Giá trị Dữ liệu</a:t>
+              <a:t>Không gian Màn hình </a:t>
+            </a:r>
+            <a:r>
+              <a:rPr sz="3000" b="1" i="0" smtClean="0">
+                <a:solidFill>
+                  <a:srgbClr val="404040"/>
+                </a:solidFill>
+                <a:latin typeface="Segoe UI"/>
+              </a:rPr>
+              <a:t>vs </a:t>
+            </a:r>
+            <a:r>
+              <a:rPr sz="3000" b="1" i="0">
+                <a:solidFill>
+                  <a:srgbClr val="404040"/>
+                </a:solidFill>
+                <a:latin typeface="Segoe UI"/>
+              </a:rPr>
+              <a:t>Cấu trúc Dữ liệu</a:t>
             </a:r>
           </a:p>
         </p:txBody>
@@ -14465,7 +14519,7 @@
                 </a:solidFill>
                 <a:latin typeface="Segoe UI"/>
               </a:rPr>
-              <a:t>Không gian Giá trị Dữ liệu </a:t>
+              <a:t>Không gian Cấu trúc Dữ liệu </a:t>
             </a:r>
             <a:r>
               <a:rPr sz="1500" b="0" i="0">
@@ -14474,7 +14528,7 @@
                 </a:solidFill>
                 <a:latin typeface="Segoe UI"/>
               </a:rPr>
-              <a:t>(Data Value Space)</a:t>
+              <a:t>(Data Structure Space)</a:t>
             </a:r>
           </a:p>
         </p:txBody>
@@ -14537,7 +14591,7 @@
                 </a:solidFill>
                 <a:latin typeface="Segoe UI"/>
               </a:rPr>
-              <a:t>Thao tác trên chính dữ liệu: lấy mẫu lại (resample) ở độ phân giải cao hơn để lộ các chi tiết thực.</a:t>
+              <a:t>Thao tác trên chính dữ liệu: truy xuất hoặc lấy mẫu lại (resample) ở độ phân giải cao hơn để lộ các chi tiết thực.</a:t>
             </a:r>
           </a:p>
         </p:txBody>
@@ -14627,8 +14681,8 @@
         </p:nvSpPr>
         <p:spPr>
           <a:xfrm>
-            <a:off x="548640" y="347472"/>
-            <a:ext cx="11064240" cy="685800"/>
+            <a:off x="548640" y="417989"/>
+            <a:ext cx="11064240" cy="544765"/>
           </a:xfrm>
           <a:prstGeom prst="rect">
             <a:avLst/>
@@ -14653,7 +14707,25 @@
                 </a:solidFill>
                 <a:latin typeface="Segoe UI"/>
               </a:rPr>
-              <a:t>Không gian Cấu trúc vs. Thuộc tính</a:t>
+              <a:t>Không gian Cấu trúc </a:t>
+            </a:r>
+            <a:r>
+              <a:rPr sz="3000" b="1" i="0" smtClean="0">
+                <a:solidFill>
+                  <a:srgbClr val="404040"/>
+                </a:solidFill>
+                <a:latin typeface="Segoe UI"/>
+              </a:rPr>
+              <a:t>vs </a:t>
+            </a:r>
+            <a:r>
+              <a:rPr sz="3000" b="1" i="0">
+                <a:solidFill>
+                  <a:srgbClr val="404040"/>
+                </a:solidFill>
+                <a:latin typeface="Segoe UI"/>
+              </a:rPr>
+              <a:t>Thuộc tính</a:t>
             </a:r>
           </a:p>
         </p:txBody>

</xml_diff>